<commit_message>
Integrate Overleaf revision into Qwen Luna comparison manuscript
</commit_message>
<xml_diff>
--- a/figures/biocoloop_framework_v2.pptx
+++ b/figures/biocoloop_framework_v2.pptx
@@ -1795,7 +1795,7 @@
                 <a:ea typeface="Carlito" pitchFamily="34" charset="-122"/>
                 <a:cs typeface="Carlito" pitchFamily="34" charset="-120"/>
               </a:rPr>
-              <a:t>Prediction head +</a:t>
+              <a:t>Resolve full recipe;</a:t>
             </a:r>
             <a:endParaRPr lang="en-US" sz="1520" dirty="0"/>
           </a:p>
@@ -1815,7 +1815,7 @@
                 <a:ea typeface="Carlito" pitchFamily="34" charset="-122"/>
                 <a:cs typeface="Carlito" pitchFamily="34" charset="-120"/>
               </a:rPr>
-              <a:t>training settings</a:t>
+              <a:t>build executable candidate</a:t>
             </a:r>
             <a:endParaRPr lang="en-US" sz="1520" dirty="0"/>
           </a:p>
@@ -2018,7 +2018,7 @@
                 <a:ea typeface="Carlito" pitchFamily="34" charset="-122"/>
                 <a:cs typeface="Carlito" pitchFamily="34" charset="-120"/>
               </a:rPr>
-              <a:t>Run candidate;</a:t>
+              <a:t>Fit locally; return</a:t>
             </a:r>
             <a:endParaRPr lang="en-US" sz="1520" dirty="0"/>
           </a:p>
@@ -2038,7 +2038,7 @@
                 <a:ea typeface="Carlito" pitchFamily="34" charset="-122"/>
                 <a:cs typeface="Carlito" pitchFamily="34" charset="-120"/>
               </a:rPr>
-              <a:t>collect diagnostics</a:t>
+              <a:t>scores + diagnostics</a:t>
             </a:r>
             <a:endParaRPr lang="en-US" sz="1520" dirty="0"/>
           </a:p>
@@ -2241,7 +2241,7 @@
                 <a:ea typeface="Carlito" pitchFamily="34" charset="-122"/>
                 <a:cs typeface="Carlito" pitchFamily="34" charset="-120"/>
               </a:rPr>
-              <a:t>Compare development;</a:t>
+              <a:t>Higher mean dev score;</a:t>
             </a:r>
             <a:endParaRPr lang="en-US" sz="1520" dirty="0"/>
           </a:p>
@@ -2261,7 +2261,7 @@
                 <a:ea typeface="Carlito" pitchFamily="34" charset="-122"/>
                 <a:cs typeface="Carlito" pitchFamily="34" charset="-120"/>
               </a:rPr>
-              <a:t>record trial outcome</a:t>
+              <a:t>tie → lower mean loss</a:t>
             </a:r>
             <a:endParaRPr lang="en-US" sz="1520" dirty="0"/>
           </a:p>
@@ -2489,7 +2489,7 @@
                 <a:ea typeface="Carlito" pitchFamily="34" charset="-122"/>
                 <a:cs typeface="Carlito" pitchFamily="34" charset="-120"/>
               </a:rPr>
-              <a:t>Coordinator: aggregate parameters and development scores</a:t>
+              <a:t>Shared coordinator: run, aggregate, select</a:t>
             </a:r>
             <a:endParaRPr lang="en-US" sz="1730" dirty="0"/>
           </a:p>
@@ -2531,7 +2531,7 @@
                 <a:ea typeface="Carlito" pitchFamily="34" charset="-122"/>
                 <a:cs typeface="Carlito" pitchFamily="34" charset="-120"/>
               </a:rPr>
-              <a:t>Send shared parameters; receive local updates and evaluation metrics</a:t>
+              <a:t>Broadcast parameters; aggregate local states + development scores</a:t>
             </a:r>
             <a:endParaRPr lang="en-US" sz="1420" dirty="0"/>
           </a:p>
@@ -2598,7 +2598,7 @@
                 <a:ea typeface="Carlito" pitchFamily="34" charset="-122"/>
                 <a:cs typeface="Carlito" pitchFamily="34" charset="-120"/>
               </a:rPr>
-              <a:t>Candidate design</a:t>
+              <a:t>Candidate recipe (full config)</a:t>
             </a:r>
             <a:endParaRPr lang="en-US" sz="1420" dirty="0"/>
           </a:p>
@@ -2715,7 +2715,7 @@
                 <a:ea typeface="Carlito" pitchFamily="34" charset="-122"/>
                 <a:cs typeface="Carlito" pitchFamily="34" charset="-120"/>
               </a:rPr>
-              <a:t>Development</a:t>
+              <a:t>Dev evidence:</a:t>
             </a:r>
             <a:endParaRPr lang="en-US" sz="1370" dirty="0"/>
           </a:p>
@@ -2735,7 +2735,7 @@
                 <a:ea typeface="Carlito" pitchFamily="34" charset="-122"/>
                 <a:cs typeface="Carlito" pitchFamily="34" charset="-120"/>
               </a:rPr>
-              <a:t>evidence</a:t>
+              <a:t>score + loss + diagnostics</a:t>
             </a:r>
             <a:endParaRPr lang="en-US" sz="1370" dirty="0"/>
           </a:p>

</xml_diff>